<commit_message>
📝 Update presentation slides
</commit_message>
<xml_diff>
--- a/PRESENTATION.pptx
+++ b/PRESENTATION.pptx
@@ -8836,14 +8836,36 @@
       </p:sp>
       <p:sp>
         <p:nvSpPr>
-          <p:cNvPr id="14" name="Text 12"/>
-          <p:cNvSpPr/>
-          <p:nvPr/>
-        </p:nvSpPr>
-        <p:spPr>
-          <a:xfrm>
-            <a:off x="812731" y="3758716"/>
-            <a:ext cx="279394" cy="292079"/>
+          <p:cNvPr id="14" name="Shape 12"/>
+          <p:cNvSpPr/>
+          <p:nvPr/>
+        </p:nvSpPr>
+        <p:spPr>
+          <a:xfrm>
+            <a:off x="7442219" y="1854057"/>
+            <a:ext cx="3936965" cy="2047086"/>
+          </a:xfrm>
+          <a:prstGeom prst="roundRect">
+            <a:avLst>
+              <a:gd name="adj" fmla="val 5584"/>
+            </a:avLst>
+          </a:prstGeom>
+          <a:solidFill>
+            <a:srgbClr val="1B2B44"/>
+          </a:solidFill>
+          <a:ln/>
+        </p:spPr>
+      </p:sp>
+      <p:sp>
+        <p:nvSpPr>
+          <p:cNvPr id="15" name="Text 13"/>
+          <p:cNvSpPr/>
+          <p:nvPr/>
+        </p:nvSpPr>
+        <p:spPr>
+          <a:xfrm>
+            <a:off x="7670813" y="2082651"/>
+            <a:ext cx="3584170" cy="253994"/>
           </a:xfrm>
           <a:prstGeom prst="rect">
             <a:avLst/>
@@ -8859,35 +8881,79 @@
           <a:p>
             <a:pPr algn="l" indent="0" marL="0">
               <a:lnSpc>
-                <a:spcPts val="2100"/>
+                <a:spcPts val="1800"/>
               </a:lnSpc>
               <a:buNone/>
             </a:pPr>
             <a:r>
               <a:rPr lang="en-US" sz="1500" b="1" dirty="0">
                 <a:solidFill>
-                  <a:srgbClr val="F2B37A"/>
+                  <a:srgbClr val="F5F7FA"/>
+                </a:solidFill>
+                <a:latin typeface="IBM Plex Sans" pitchFamily="34" charset="0"/>
+                <a:ea typeface="IBM Plex Sans" pitchFamily="34" charset="-122"/>
+                <a:cs typeface="IBM Plex Sans" pitchFamily="34" charset="-120"/>
+              </a:rPr>
+              <a:t>Si on a 30 secondes de plus</a:t>
+            </a:r>
+            <a:endParaRPr lang="en-US" sz="1500" dirty="0"/>
+          </a:p>
+        </p:txBody>
+      </p:sp>
+      <p:sp>
+        <p:nvSpPr>
+          <p:cNvPr id="16" name="Text 14"/>
+          <p:cNvSpPr/>
+          <p:nvPr/>
+        </p:nvSpPr>
+        <p:spPr>
+          <a:xfrm>
+            <a:off x="7670813" y="2438195"/>
+            <a:ext cx="3584170" cy="238778"/>
+          </a:xfrm>
+          <a:prstGeom prst="rect">
+            <a:avLst/>
+          </a:prstGeom>
+          <a:noFill/>
+          <a:ln/>
+        </p:spPr>
+        <p:txBody>
+          <a:bodyPr wrap="square" lIns="0" tIns="0" rIns="0" bIns="0" rtlCol="0" anchor="t">
+            <a:normAutofit/>
+          </a:bodyPr>
+          <a:lstStyle/>
+          <a:p>
+            <a:pPr algn="l" indent="0" marL="0">
+              <a:lnSpc>
+                <a:spcPts val="1680"/>
+              </a:lnSpc>
+              <a:buNone/>
+            </a:pPr>
+            <a:r>
+              <a:rPr lang="en-US" sz="1200" dirty="0">
+                <a:solidFill>
+                  <a:srgbClr val="E6EDF7"/>
                 </a:solidFill>
                 <a:latin typeface="JetBrains Mono" pitchFamily="49" charset="0"/>
                 <a:ea typeface="JetBrains Mono" pitchFamily="49" charset="-122"/>
                 <a:cs typeface="JetBrains Mono" pitchFamily="49" charset="-120"/>
               </a:rPr>
-              <a:t>06</a:t>
-            </a:r>
-            <a:endParaRPr lang="en-US" sz="1500" dirty="0"/>
-          </a:p>
-        </p:txBody>
-      </p:sp>
-      <p:sp>
-        <p:nvSpPr>
-          <p:cNvPr id="15" name="Text 13"/>
-          <p:cNvSpPr/>
-          <p:nvPr/>
-        </p:nvSpPr>
-        <p:spPr>
-          <a:xfrm>
-            <a:off x="1168273" y="3758716"/>
-            <a:ext cx="5330372" cy="292079"/>
+              <a:t>docker compose config</a:t>
+            </a:r>
+            <a:endParaRPr lang="en-US" sz="1200" dirty="0"/>
+          </a:p>
+        </p:txBody>
+      </p:sp>
+      <p:sp>
+        <p:nvSpPr>
+          <p:cNvPr id="17" name="Text 15"/>
+          <p:cNvSpPr/>
+          <p:nvPr/>
+        </p:nvSpPr>
+        <p:spPr>
+          <a:xfrm>
+            <a:off x="7670813" y="2778522"/>
+            <a:ext cx="3708371" cy="238778"/>
           </a:xfrm>
           <a:prstGeom prst="rect">
             <a:avLst/>
@@ -8903,130 +8969,152 @@
           <a:p>
             <a:pPr algn="l" indent="0" marL="0">
               <a:lnSpc>
-                <a:spcPts val="2100"/>
-              </a:lnSpc>
-              <a:buNone/>
-            </a:pPr>
-            <a:r>
-              <a:rPr lang="en-US" sz="1500" dirty="0">
-                <a:solidFill>
-                  <a:srgbClr val="F5F7FA"/>
+                <a:spcPts val="1680"/>
+              </a:lnSpc>
+              <a:buNone/>
+            </a:pPr>
+            <a:r>
+              <a:rPr lang="en-US" sz="1200" dirty="0">
+                <a:solidFill>
+                  <a:srgbClr val="E6EDF7"/>
+                </a:solidFill>
+                <a:latin typeface="JetBrains Mono" pitchFamily="49" charset="0"/>
+                <a:ea typeface="JetBrains Mono" pitchFamily="49" charset="-122"/>
+                <a:cs typeface="JetBrains Mono" pitchFamily="49" charset="-120"/>
+              </a:rPr>
+              <a:t>docker network inspect docker_backend</a:t>
+            </a:r>
+            <a:endParaRPr lang="en-US" sz="1200" dirty="0"/>
+          </a:p>
+        </p:txBody>
+      </p:sp>
+      <p:sp>
+        <p:nvSpPr>
+          <p:cNvPr id="18" name="Text 16"/>
+          <p:cNvSpPr/>
+          <p:nvPr/>
+        </p:nvSpPr>
+        <p:spPr>
+          <a:xfrm>
+            <a:off x="7670813" y="3118848"/>
+            <a:ext cx="3584170" cy="238778"/>
+          </a:xfrm>
+          <a:prstGeom prst="rect">
+            <a:avLst/>
+          </a:prstGeom>
+          <a:noFill/>
+          <a:ln/>
+        </p:spPr>
+        <p:txBody>
+          <a:bodyPr wrap="square" lIns="0" tIns="0" rIns="0" bIns="0" rtlCol="0" anchor="t">
+            <a:normAutofit/>
+          </a:bodyPr>
+          <a:lstStyle/>
+          <a:p>
+            <a:pPr algn="l" indent="0" marL="0">
+              <a:lnSpc>
+                <a:spcPts val="1680"/>
+              </a:lnSpc>
+              <a:buNone/>
+            </a:pPr>
+            <a:r>
+              <a:rPr lang="en-US" sz="1200" dirty="0">
+                <a:solidFill>
+                  <a:srgbClr val="E6EDF7"/>
+                </a:solidFill>
+                <a:latin typeface="JetBrains Mono" pitchFamily="49" charset="0"/>
+                <a:ea typeface="JetBrains Mono" pitchFamily="49" charset="-122"/>
+                <a:cs typeface="JetBrains Mono" pitchFamily="49" charset="-120"/>
+              </a:rPr>
+              <a:t>docker stats --no-stream</a:t>
+            </a:r>
+            <a:endParaRPr lang="en-US" sz="1200" dirty="0"/>
+          </a:p>
+        </p:txBody>
+      </p:sp>
+      <p:sp>
+        <p:nvSpPr>
+          <p:cNvPr id="19" name="Text 17"/>
+          <p:cNvSpPr/>
+          <p:nvPr/>
+        </p:nvSpPr>
+        <p:spPr>
+          <a:xfrm>
+            <a:off x="7670813" y="3459175"/>
+            <a:ext cx="3584170" cy="238778"/>
+          </a:xfrm>
+          <a:prstGeom prst="rect">
+            <a:avLst/>
+          </a:prstGeom>
+          <a:noFill/>
+          <a:ln/>
+        </p:spPr>
+        <p:txBody>
+          <a:bodyPr wrap="square" lIns="0" tIns="0" rIns="0" bIns="0" rtlCol="0" anchor="t">
+            <a:normAutofit/>
+          </a:bodyPr>
+          <a:lstStyle/>
+          <a:p>
+            <a:pPr algn="l" indent="0" marL="0">
+              <a:lnSpc>
+                <a:spcPts val="1680"/>
+              </a:lnSpc>
+              <a:buNone/>
+            </a:pPr>
+            <a:r>
+              <a:rPr lang="en-US" sz="1200" dirty="0">
+                <a:solidFill>
+                  <a:srgbClr val="E6EDF7"/>
+                </a:solidFill>
+                <a:latin typeface="JetBrains Mono" pitchFamily="49" charset="0"/>
+                <a:ea typeface="JetBrains Mono" pitchFamily="49" charset="-122"/>
+                <a:cs typeface="JetBrains Mono" pitchFamily="49" charset="-120"/>
+              </a:rPr>
+              <a:t>docker image ls</a:t>
+            </a:r>
+            <a:endParaRPr lang="en-US" sz="1200" dirty="0"/>
+          </a:p>
+        </p:txBody>
+      </p:sp>
+      <p:sp>
+        <p:nvSpPr>
+          <p:cNvPr id="20" name="Text 18"/>
+          <p:cNvSpPr/>
+          <p:nvPr/>
+        </p:nvSpPr>
+        <p:spPr>
+          <a:xfrm>
+            <a:off x="812731" y="6235688"/>
+            <a:ext cx="2760554" cy="241299"/>
+          </a:xfrm>
+          <a:prstGeom prst="rect">
+            <a:avLst/>
+          </a:prstGeom>
+          <a:noFill/>
+          <a:ln/>
+        </p:spPr>
+        <p:txBody>
+          <a:bodyPr wrap="square" lIns="0" tIns="0" rIns="0" bIns="0" rtlCol="0" anchor="t">
+            <a:normAutofit/>
+          </a:bodyPr>
+          <a:lstStyle/>
+          <a:p>
+            <a:pPr algn="l" indent="0" marL="0">
+              <a:lnSpc>
+                <a:spcPts val="1680"/>
+              </a:lnSpc>
+              <a:buNone/>
+            </a:pPr>
+            <a:r>
+              <a:rPr lang="en-US" sz="1200" dirty="0">
+                <a:solidFill>
+                  <a:srgbClr val="B4C0D3"/>
                 </a:solidFill>
                 <a:latin typeface="IBM Plex Sans" pitchFamily="34" charset="0"/>
                 <a:ea typeface="IBM Plex Sans" pitchFamily="34" charset="-122"/>
                 <a:cs typeface="IBM Plex Sans" pitchFamily="34" charset="-120"/>
               </a:rPr>
-              <a:t>Watch : on modifie nginx.conf, Nginx redémarre seul</a:t>
-            </a:r>
-            <a:endParaRPr lang="en-US" sz="1500" dirty="0"/>
-          </a:p>
-        </p:txBody>
-      </p:sp>
-      <p:sp>
-        <p:nvSpPr>
-          <p:cNvPr id="16" name="Shape 14"/>
-          <p:cNvSpPr/>
-          <p:nvPr/>
-        </p:nvSpPr>
-        <p:spPr>
-          <a:xfrm>
-            <a:off x="7442219" y="1854057"/>
-            <a:ext cx="3936965" cy="2171339"/>
-          </a:xfrm>
-          <a:prstGeom prst="roundRect">
-            <a:avLst>
-              <a:gd name="adj" fmla="val 5264"/>
-            </a:avLst>
-          </a:prstGeom>
-          <a:solidFill>
-            <a:srgbClr val="1B2B44"/>
-          </a:solidFill>
-          <a:ln/>
-        </p:spPr>
-      </p:sp>
-      <p:sp>
-        <p:nvSpPr>
-          <p:cNvPr id="17" name="Text 15"/>
-          <p:cNvSpPr/>
-          <p:nvPr/>
-        </p:nvSpPr>
-        <p:spPr>
-          <a:xfrm>
-            <a:off x="7670813" y="2082651"/>
-            <a:ext cx="3584170" cy="253994"/>
-          </a:xfrm>
-          <a:prstGeom prst="rect">
-            <a:avLst/>
-          </a:prstGeom>
-          <a:noFill/>
-          <a:ln/>
-        </p:spPr>
-        <p:txBody>
-          <a:bodyPr wrap="square" lIns="0" tIns="0" rIns="0" bIns="0" rtlCol="0" anchor="t">
-            <a:normAutofit/>
-          </a:bodyPr>
-          <a:lstStyle/>
-          <a:p>
-            <a:pPr algn="l" indent="0" marL="0">
-              <a:lnSpc>
-                <a:spcPts val="1800"/>
-              </a:lnSpc>
-              <a:buNone/>
-            </a:pPr>
-            <a:r>
-              <a:rPr lang="en-US" sz="1500" b="1" dirty="0">
-                <a:solidFill>
-                  <a:srgbClr val="F5F7FA"/>
-                </a:solidFill>
-                <a:latin typeface="IBM Plex Sans" pitchFamily="34" charset="0"/>
-                <a:ea typeface="IBM Plex Sans" pitchFamily="34" charset="-122"/>
-                <a:cs typeface="IBM Plex Sans" pitchFamily="34" charset="-120"/>
-              </a:rPr>
-              <a:t>Si on a 30 secondes de plus</a:t>
-            </a:r>
-            <a:endParaRPr lang="en-US" sz="1500" dirty="0"/>
-          </a:p>
-        </p:txBody>
-      </p:sp>
-      <p:sp>
-        <p:nvSpPr>
-          <p:cNvPr id="18" name="Text 16"/>
-          <p:cNvSpPr/>
-          <p:nvPr/>
-        </p:nvSpPr>
-        <p:spPr>
-          <a:xfrm>
-            <a:off x="7670813" y="2438195"/>
-            <a:ext cx="3584170" cy="238778"/>
-          </a:xfrm>
-          <a:prstGeom prst="rect">
-            <a:avLst/>
-          </a:prstGeom>
-          <a:noFill/>
-          <a:ln/>
-        </p:spPr>
-        <p:txBody>
-          <a:bodyPr wrap="square" lIns="0" tIns="0" rIns="0" bIns="0" rtlCol="0" anchor="t">
-            <a:normAutofit/>
-          </a:bodyPr>
-          <a:lstStyle/>
-          <a:p>
-            <a:pPr algn="l" indent="0" marL="0">
-              <a:lnSpc>
-                <a:spcPts val="1680"/>
-              </a:lnSpc>
-              <a:buNone/>
-            </a:pPr>
-            <a:r>
-              <a:rPr lang="en-US" sz="1200" dirty="0">
-                <a:solidFill>
-                  <a:srgbClr val="E6EDF7"/>
-                </a:solidFill>
-                <a:latin typeface="JetBrains Mono" pitchFamily="49" charset="0"/>
-                <a:ea typeface="JetBrains Mono" pitchFamily="49" charset="-122"/>
-                <a:cs typeface="JetBrains Mono" pitchFamily="49" charset="-120"/>
-              </a:rPr>
-              <a:t>docker compose config</a:t>
+              <a:t>IM Bridge · Mattermost ⇄ Discord</a:t>
             </a:r>
             <a:endParaRPr lang="en-US" sz="1200" dirty="0"/>
           </a:p>
@@ -9034,183 +9122,7 @@
       </p:sp>
       <p:sp>
         <p:nvSpPr>
-          <p:cNvPr id="19" name="Text 17"/>
-          <p:cNvSpPr/>
-          <p:nvPr/>
-        </p:nvSpPr>
-        <p:spPr>
-          <a:xfrm>
-            <a:off x="7670813" y="2778522"/>
-            <a:ext cx="3708371" cy="238778"/>
-          </a:xfrm>
-          <a:prstGeom prst="rect">
-            <a:avLst/>
-          </a:prstGeom>
-          <a:noFill/>
-          <a:ln/>
-        </p:spPr>
-        <p:txBody>
-          <a:bodyPr wrap="square" lIns="0" tIns="0" rIns="0" bIns="0" rtlCol="0" anchor="t">
-            <a:normAutofit/>
-          </a:bodyPr>
-          <a:lstStyle/>
-          <a:p>
-            <a:pPr algn="l" indent="0" marL="0">
-              <a:lnSpc>
-                <a:spcPts val="1680"/>
-              </a:lnSpc>
-              <a:buNone/>
-            </a:pPr>
-            <a:r>
-              <a:rPr lang="en-US" sz="1200" dirty="0">
-                <a:solidFill>
-                  <a:srgbClr val="E6EDF7"/>
-                </a:solidFill>
-                <a:latin typeface="JetBrains Mono" pitchFamily="49" charset="0"/>
-                <a:ea typeface="JetBrains Mono" pitchFamily="49" charset="-122"/>
-                <a:cs typeface="JetBrains Mono" pitchFamily="49" charset="-120"/>
-              </a:rPr>
-              <a:t>docker network inspect docker_backend</a:t>
-            </a:r>
-            <a:endParaRPr lang="en-US" sz="1200" dirty="0"/>
-          </a:p>
-        </p:txBody>
-      </p:sp>
-      <p:sp>
-        <p:nvSpPr>
-          <p:cNvPr id="20" name="Text 18"/>
-          <p:cNvSpPr/>
-          <p:nvPr/>
-        </p:nvSpPr>
-        <p:spPr>
-          <a:xfrm>
-            <a:off x="7670813" y="3118848"/>
-            <a:ext cx="3584170" cy="238778"/>
-          </a:xfrm>
-          <a:prstGeom prst="rect">
-            <a:avLst/>
-          </a:prstGeom>
-          <a:noFill/>
-          <a:ln/>
-        </p:spPr>
-        <p:txBody>
-          <a:bodyPr wrap="square" lIns="0" tIns="0" rIns="0" bIns="0" rtlCol="0" anchor="t">
-            <a:normAutofit/>
-          </a:bodyPr>
-          <a:lstStyle/>
-          <a:p>
-            <a:pPr algn="l" indent="0" marL="0">
-              <a:lnSpc>
-                <a:spcPts val="1680"/>
-              </a:lnSpc>
-              <a:buNone/>
-            </a:pPr>
-            <a:r>
-              <a:rPr lang="en-US" sz="1200" dirty="0">
-                <a:solidFill>
-                  <a:srgbClr val="E6EDF7"/>
-                </a:solidFill>
-                <a:latin typeface="JetBrains Mono" pitchFamily="49" charset="0"/>
-                <a:ea typeface="JetBrains Mono" pitchFamily="49" charset="-122"/>
-                <a:cs typeface="JetBrains Mono" pitchFamily="49" charset="-120"/>
-              </a:rPr>
-              <a:t>docker stats --no-stream</a:t>
-            </a:r>
-            <a:endParaRPr lang="en-US" sz="1200" dirty="0"/>
-          </a:p>
-        </p:txBody>
-      </p:sp>
-      <p:sp>
-        <p:nvSpPr>
           <p:cNvPr id="21" name="Text 19"/>
-          <p:cNvSpPr/>
-          <p:nvPr/>
-        </p:nvSpPr>
-        <p:spPr>
-          <a:xfrm>
-            <a:off x="7670813" y="3459175"/>
-            <a:ext cx="3584170" cy="238778"/>
-          </a:xfrm>
-          <a:prstGeom prst="rect">
-            <a:avLst/>
-          </a:prstGeom>
-          <a:noFill/>
-          <a:ln/>
-        </p:spPr>
-        <p:txBody>
-          <a:bodyPr wrap="square" lIns="0" tIns="0" rIns="0" bIns="0" rtlCol="0" anchor="t">
-            <a:normAutofit/>
-          </a:bodyPr>
-          <a:lstStyle/>
-          <a:p>
-            <a:pPr algn="l" indent="0" marL="0">
-              <a:lnSpc>
-                <a:spcPts val="1680"/>
-              </a:lnSpc>
-              <a:buNone/>
-            </a:pPr>
-            <a:r>
-              <a:rPr lang="en-US" sz="1200" dirty="0">
-                <a:solidFill>
-                  <a:srgbClr val="E6EDF7"/>
-                </a:solidFill>
-                <a:latin typeface="JetBrains Mono" pitchFamily="49" charset="0"/>
-                <a:ea typeface="JetBrains Mono" pitchFamily="49" charset="-122"/>
-                <a:cs typeface="JetBrains Mono" pitchFamily="49" charset="-120"/>
-              </a:rPr>
-              <a:t>docker image ls</a:t>
-            </a:r>
-            <a:endParaRPr lang="en-US" sz="1200" dirty="0"/>
-          </a:p>
-        </p:txBody>
-      </p:sp>
-      <p:sp>
-        <p:nvSpPr>
-          <p:cNvPr id="22" name="Text 20"/>
-          <p:cNvSpPr/>
-          <p:nvPr/>
-        </p:nvSpPr>
-        <p:spPr>
-          <a:xfrm>
-            <a:off x="812731" y="6235688"/>
-            <a:ext cx="2760554" cy="241299"/>
-          </a:xfrm>
-          <a:prstGeom prst="rect">
-            <a:avLst/>
-          </a:prstGeom>
-          <a:noFill/>
-          <a:ln/>
-        </p:spPr>
-        <p:txBody>
-          <a:bodyPr wrap="square" lIns="0" tIns="0" rIns="0" bIns="0" rtlCol="0" anchor="t">
-            <a:normAutofit/>
-          </a:bodyPr>
-          <a:lstStyle/>
-          <a:p>
-            <a:pPr algn="l" indent="0" marL="0">
-              <a:lnSpc>
-                <a:spcPts val="1680"/>
-              </a:lnSpc>
-              <a:buNone/>
-            </a:pPr>
-            <a:r>
-              <a:rPr lang="en-US" sz="1200" dirty="0">
-                <a:solidFill>
-                  <a:srgbClr val="B4C0D3"/>
-                </a:solidFill>
-                <a:latin typeface="IBM Plex Sans" pitchFamily="34" charset="0"/>
-                <a:ea typeface="IBM Plex Sans" pitchFamily="34" charset="-122"/>
-                <a:cs typeface="IBM Plex Sans" pitchFamily="34" charset="-120"/>
-              </a:rPr>
-              <a:t>IM Bridge · Mattermost ⇄ Discord</a:t>
-            </a:r>
-            <a:endParaRPr lang="en-US" sz="1200" dirty="0"/>
-          </a:p>
-        </p:txBody>
-      </p:sp>
-      <p:sp>
-        <p:nvSpPr>
-          <p:cNvPr id="23" name="Text 21"/>
           <p:cNvSpPr/>
           <p:nvPr/>
         </p:nvSpPr>
@@ -18915,7 +18827,7 @@
         <a:srgbClr val="B45309"/>
       </a:accent5>
       <a:accent6>
-        <a:srgbClr val="F2B37A"/>
+        <a:srgbClr val="46536A"/>
       </a:accent6>
       <a:hlink>
         <a:srgbClr val="0563C1"/>

</xml_diff>

<commit_message>
📝 Update presentation content
</commit_message>
<xml_diff>
--- a/PRESENTATION.pptx
+++ b/PRESENTATION.pptx
@@ -9720,7 +9720,7 @@
         <p:spPr>
           <a:xfrm>
             <a:off x="1142883" y="3987310"/>
-            <a:ext cx="3507845" cy="292079"/>
+            <a:ext cx="2325451" cy="292079"/>
           </a:xfrm>
           <a:prstGeom prst="rect">
             <a:avLst/>
@@ -9749,7 +9749,7 @@
                 <a:ea typeface="IBM Plex Sans" pitchFamily="34" charset="-122"/>
                 <a:cs typeface="IBM Plex Sans" pitchFamily="34" charset="-120"/>
               </a:rPr>
-              <a:t>Fragments, cgroups, healthchecks</a:t>
+              <a:t>Cgroups, healthchecks</a:t>
             </a:r>
             <a:endParaRPr lang="en-US" sz="1500" dirty="0"/>
           </a:p>

</xml_diff>